<commit_message>
fix(contact): update official email to admin@maudynetwork.id and WhatsApp to 0852-3319-5874
</commit_message>
<xml_diff>
--- a/exports/XTUR-AI-Surveillance-Product-Profile.pptx
+++ b/exports/XTUR-AI-Surveillance-Product-Profile.pptx
@@ -4554,7 +4554,7 @@
         </p:nvSpPr>
         <p:spPr>
           <a:xfrm>
-            <a:off x="1005840" y="2788920"/>
+            <a:off x="1005840" y="2743200"/>
             <a:ext cx="7132320" cy="0"/>
           </a:xfrm>
           <a:prstGeom prst="rect">
@@ -4569,12 +4569,12 @@
           <a:p>
             <a:pPr indent="0" marL="0">
               <a:lnSpc>
-                <a:spcPts val="1600"/>
+                <a:spcPts val="1500"/>
               </a:lnSpc>
               <a:buNone/>
             </a:pPr>
             <a:r>
-              <a:rPr lang="en-US" sz="1000" dirty="0">
+              <a:rPr lang="en-US" sz="950" dirty="0">
                 <a:solidFill>
                   <a:srgbClr val="93C5FD"/>
                 </a:solidFill>
@@ -4584,26 +4584,26 @@
               </a:rPr>
               <a:t>Penyedia Solusi AI Vision Surveillance &amp; Sistem Keamanan Terpadu Indonesia</a:t>
             </a:r>
-            <a:endParaRPr lang="en-US" sz="1000" dirty="0"/>
+            <a:endParaRPr lang="en-US" sz="950" dirty="0"/>
           </a:p>
           <a:p>
             <a:pPr indent="0" marL="0">
               <a:lnSpc>
-                <a:spcPts val="1600"/>
+                <a:spcPts val="1500"/>
               </a:lnSpc>
               <a:buNone/>
             </a:pPr>
-            <a:endParaRPr lang="en-US" sz="1000" dirty="0"/>
+            <a:endParaRPr lang="en-US" sz="950" dirty="0"/>
           </a:p>
           <a:p>
             <a:pPr indent="0" marL="0">
               <a:lnSpc>
-                <a:spcPts val="1600"/>
+                <a:spcPts val="1500"/>
               </a:lnSpc>
               <a:buNone/>
             </a:pPr>
             <a:r>
-              <a:rPr lang="en-US" sz="1000" dirty="0">
+              <a:rPr lang="en-US" sz="950" dirty="0">
                 <a:solidFill>
                   <a:srgbClr val="93C5FD"/>
                 </a:solidFill>
@@ -4613,17 +4613,17 @@
               </a:rPr>
               <a:t>• Portal Resmi Platform : xtur.exac.site</a:t>
             </a:r>
-            <a:endParaRPr lang="en-US" sz="1000" dirty="0"/>
+            <a:endParaRPr lang="en-US" sz="950" dirty="0"/>
           </a:p>
           <a:p>
             <a:pPr indent="0" marL="0">
               <a:lnSpc>
-                <a:spcPts val="1600"/>
+                <a:spcPts val="1500"/>
               </a:lnSpc>
               <a:buNone/>
             </a:pPr>
             <a:r>
-              <a:rPr lang="en-US" sz="1000" dirty="0">
+              <a:rPr lang="en-US" sz="950" dirty="0">
                 <a:solidFill>
                   <a:srgbClr val="93C5FD"/>
                 </a:solidFill>
@@ -4631,19 +4631,19 @@
                 <a:ea typeface="Calibri" pitchFamily="34" charset="-122"/>
                 <a:cs typeface="Calibri" pitchFamily="34" charset="-120"/>
               </a:rPr>
-              <a:t>• Alamat Surel (Email)  : contact@maudy.network | support@xtur.exac.site</a:t>
-            </a:r>
-            <a:endParaRPr lang="en-US" sz="1000" dirty="0"/>
+              <a:t>• Email Resmi Perusahaan: admin@maudynetwork.id</a:t>
+            </a:r>
+            <a:endParaRPr lang="en-US" sz="950" dirty="0"/>
           </a:p>
           <a:p>
             <a:pPr indent="0" marL="0">
               <a:lnSpc>
-                <a:spcPts val="1600"/>
+                <a:spcPts val="1500"/>
               </a:lnSpc>
               <a:buNone/>
             </a:pPr>
             <a:r>
-              <a:rPr lang="en-US" sz="1000" dirty="0">
+              <a:rPr lang="en-US" sz="950" dirty="0">
                 <a:solidFill>
                   <a:srgbClr val="93C5FD"/>
                 </a:solidFill>
@@ -4651,19 +4651,39 @@
                 <a:ea typeface="Calibri" pitchFamily="34" charset="-122"/>
                 <a:cs typeface="Calibri" pitchFamily="34" charset="-120"/>
               </a:rPr>
+              <a:t>• WhatsApp &amp; Hotline    : 0852-3319-5874 (CV Maudy Network Komunikasi)</a:t>
+            </a:r>
+            <a:endParaRPr lang="en-US" sz="950" dirty="0"/>
+          </a:p>
+          <a:p>
+            <a:pPr indent="0" marL="0">
+              <a:lnSpc>
+                <a:spcPts val="1500"/>
+              </a:lnSpc>
+              <a:buNone/>
+            </a:pPr>
+            <a:r>
+              <a:rPr lang="en-US" sz="950" dirty="0">
+                <a:solidFill>
+                  <a:srgbClr val="93C5FD"/>
+                </a:solidFill>
+                <a:latin typeface="Calibri" pitchFamily="34" charset="0"/>
+                <a:ea typeface="Calibri" pitchFamily="34" charset="-122"/>
+                <a:cs typeface="Calibri" pitchFamily="34" charset="-120"/>
+              </a:rPr>
               <a:t>• Layanan Kemitraan     : Konsultasi Arsitektur, Proof of Concept (POC), &amp; Onsite Deployment</a:t>
             </a:r>
-            <a:endParaRPr lang="en-US" sz="1000" dirty="0"/>
+            <a:endParaRPr lang="en-US" sz="950" dirty="0"/>
           </a:p>
           <a:p>
             <a:pPr indent="0" marL="0">
               <a:lnSpc>
-                <a:spcPts val="1600"/>
+                <a:spcPts val="1500"/>
               </a:lnSpc>
               <a:buNone/>
             </a:pPr>
             <a:r>
-              <a:rPr lang="en-US" sz="1000" dirty="0">
+              <a:rPr lang="en-US" sz="950" dirty="0">
                 <a:solidFill>
                   <a:srgbClr val="93C5FD"/>
                 </a:solidFill>
@@ -4673,7 +4693,7 @@
               </a:rPr>
               <a:t>• Cakupan Wilayah       : Seluruh Wilayah Republik Indonesia</a:t>
             </a:r>
-            <a:endParaRPr lang="en-US" sz="1000" dirty="0"/>
+            <a:endParaRPr lang="en-US" sz="950" dirty="0"/>
           </a:p>
         </p:txBody>
       </p:sp>

</xml_diff>

<commit_message>
fix(branding): change 'CV Maudy Network Komunikasi' to 'Maudy Network Komunikasi'
</commit_message>
<xml_diff>
--- a/exports/XTUR-AI-Surveillance-Product-Profile.pptx
+++ b/exports/XTUR-AI-Surveillance-Product-Profile.pptx
@@ -2467,7 +2467,7 @@
                 <a:ea typeface="Calibri" pitchFamily="34" charset="-122"/>
                 <a:cs typeface="Calibri" pitchFamily="34" charset="-120"/>
               </a:rPr>
-              <a:t>Diterbitkan Resmi Oleh: CV Maudy Network Komunikasi — Edisi Profil Produk 2026</a:t>
+              <a:t>Diterbitkan Resmi Oleh: Maudy Network Komunikasi — Edisi Profil Produk 2026</a:t>
             </a:r>
             <a:endParaRPr lang="en-US" sz="950" dirty="0"/>
           </a:p>
@@ -2664,7 +2664,7 @@
                 <a:ea typeface="Calibri" pitchFamily="34" charset="-122"/>
                 <a:cs typeface="Calibri" pitchFamily="34" charset="-120"/>
               </a:rPr>
-              <a:t>CV MAUDY NETWORK KOMUNIKASI</a:t>
+              <a:t>MAUDY NETWORK KOMUNIKASI</a:t>
             </a:r>
             <a:endParaRPr lang="en-US" sz="750" dirty="0"/>
           </a:p>
@@ -3270,7 +3270,7 @@
                 <a:ea typeface="Calibri" pitchFamily="34" charset="-122"/>
                 <a:cs typeface="Calibri" pitchFamily="34" charset="-120"/>
               </a:rPr>
-              <a:t>CV MAUDY NETWORK KOMUNIKASI</a:t>
+              <a:t>MAUDY NETWORK KOMUNIKASI</a:t>
             </a:r>
             <a:endParaRPr lang="en-US" sz="750" dirty="0"/>
           </a:p>
@@ -4540,7 +4540,7 @@
                 <a:ea typeface="Calibri" pitchFamily="34" charset="-122"/>
                 <a:cs typeface="Calibri" pitchFamily="34" charset="-120"/>
               </a:rPr>
-              <a:t>CV MAUDY NETWORK KOMUNIKASI</a:t>
+              <a:t>MAUDY NETWORK KOMUNIKASI</a:t>
             </a:r>
             <a:endParaRPr lang="en-US" sz="1400" dirty="0"/>
           </a:p>
@@ -4651,7 +4651,7 @@
                 <a:ea typeface="Calibri" pitchFamily="34" charset="-122"/>
                 <a:cs typeface="Calibri" pitchFamily="34" charset="-120"/>
               </a:rPr>
-              <a:t>• WhatsApp &amp; Hotline    : 0852-3319-5874 (CV Maudy Network Komunikasi)</a:t>
+              <a:t>• WhatsApp &amp; Hotline    : 0852-3319-5874 (Maudy Network Komunikasi)</a:t>
             </a:r>
             <a:endParaRPr lang="en-US" sz="950" dirty="0"/>
           </a:p>
@@ -4730,7 +4730,7 @@
                 <a:ea typeface="Calibri" pitchFamily="34" charset="-122"/>
                 <a:cs typeface="Calibri" pitchFamily="34" charset="-120"/>
               </a:rPr>
-              <a:t>© 2026 CV Maudy Network Komunikasi. Seluruh hak cipta dilindungi undang-undang.</a:t>
+              <a:t>© 2026 Maudy Network Komunikasi. Seluruh hak cipta dilindungi undang-undang.</a:t>
             </a:r>
             <a:endParaRPr lang="en-US" sz="900" dirty="0"/>
           </a:p>
@@ -4927,7 +4927,7 @@
                 <a:ea typeface="Calibri" pitchFamily="34" charset="-122"/>
                 <a:cs typeface="Calibri" pitchFamily="34" charset="-120"/>
               </a:rPr>
-              <a:t>CV MAUDY NETWORK KOMUNIKASI</a:t>
+              <a:t>MAUDY NETWORK KOMUNIKASI</a:t>
             </a:r>
             <a:endParaRPr lang="en-US" sz="750" dirty="0"/>
           </a:p>
@@ -5549,7 +5549,7 @@
                 <a:ea typeface="Calibri" pitchFamily="34" charset="-122"/>
                 <a:cs typeface="Calibri" pitchFamily="34" charset="-120"/>
               </a:rPr>
-              <a:t>CV MAUDY NETWORK KOMUNIKASI</a:t>
+              <a:t>MAUDY NETWORK KOMUNIKASI</a:t>
             </a:r>
             <a:endParaRPr lang="en-US" sz="750" dirty="0"/>
           </a:p>
@@ -6272,7 +6272,7 @@
                 <a:ea typeface="Calibri" pitchFamily="34" charset="-122"/>
                 <a:cs typeface="Calibri" pitchFamily="34" charset="-120"/>
               </a:rPr>
-              <a:t>CV MAUDY NETWORK KOMUNIKASI</a:t>
+              <a:t>MAUDY NETWORK KOMUNIKASI</a:t>
             </a:r>
             <a:endParaRPr lang="en-US" sz="750" dirty="0"/>
           </a:p>
@@ -6971,7 +6971,7 @@
                 <a:ea typeface="Calibri" pitchFamily="34" charset="-122"/>
                 <a:cs typeface="Calibri" pitchFamily="34" charset="-120"/>
               </a:rPr>
-              <a:t>CV MAUDY NETWORK KOMUNIKASI</a:t>
+              <a:t>MAUDY NETWORK KOMUNIKASI</a:t>
             </a:r>
             <a:endParaRPr lang="en-US" sz="750" dirty="0"/>
           </a:p>
@@ -8248,7 +8248,7 @@
                 <a:ea typeface="Calibri" pitchFamily="34" charset="-122"/>
                 <a:cs typeface="Calibri" pitchFamily="34" charset="-120"/>
               </a:rPr>
-              <a:t>CV MAUDY NETWORK KOMUNIKASI</a:t>
+              <a:t>MAUDY NETWORK KOMUNIKASI</a:t>
             </a:r>
             <a:endParaRPr lang="en-US" sz="750" dirty="0"/>
           </a:p>
@@ -8854,7 +8854,7 @@
                 <a:ea typeface="Calibri" pitchFamily="34" charset="-122"/>
                 <a:cs typeface="Calibri" pitchFamily="34" charset="-120"/>
               </a:rPr>
-              <a:t>CV MAUDY NETWORK KOMUNIKASI</a:t>
+              <a:t>MAUDY NETWORK KOMUNIKASI</a:t>
             </a:r>
             <a:endParaRPr lang="en-US" sz="750" dirty="0"/>
           </a:p>
@@ -9460,7 +9460,7 @@
                 <a:ea typeface="Calibri" pitchFamily="34" charset="-122"/>
                 <a:cs typeface="Calibri" pitchFamily="34" charset="-120"/>
               </a:rPr>
-              <a:t>CV MAUDY NETWORK KOMUNIKASI</a:t>
+              <a:t>MAUDY NETWORK KOMUNIKASI</a:t>
             </a:r>
             <a:endParaRPr lang="en-US" sz="750" dirty="0"/>
           </a:p>
@@ -10037,7 +10037,7 @@
                 <a:ea typeface="Calibri" pitchFamily="34" charset="-122"/>
                 <a:cs typeface="Calibri" pitchFamily="34" charset="-120"/>
               </a:rPr>
-              <a:t>CV MAUDY NETWORK KOMUNIKASI</a:t>
+              <a:t>MAUDY NETWORK KOMUNIKASI</a:t>
             </a:r>
             <a:endParaRPr lang="en-US" sz="750" dirty="0"/>
           </a:p>

</xml_diff>